<commit_message>
update compare batch and stream slides
</commit_message>
<xml_diff>
--- a/baocao.pptx
+++ b/baocao.pptx
@@ -4500,7 +4500,7 @@
           <a:p>
             <a:fld id="{CEEBDA6D-DC69-4DCE-BAF7-6763517D3376}" type="datetimeFigureOut">
               <a:rPr lang="en-US"/>
-              <a:t>4/28/2026</a:t>
+              <a:t>5/2/2026</a:t>
             </a:fld>
             <a:endParaRPr/>
           </a:p>
@@ -4665,7 +4665,7 @@
           <a:p>
             <a:fld id="{237F6C43-988E-4257-9A1C-C162EF036D58}" type="datetimeFigureOut">
               <a:rPr lang="en-US"/>
-              <a:t>4/28/2026</a:t>
+              <a:t>5/2/2026</a:t>
             </a:fld>
             <a:endParaRPr/>
           </a:p>
@@ -5183,7 +5183,7 @@
             <a:fld id="{2CCFE9AC-F15C-4FA0-A6F1-298829FA691D}" type="datetimeFigureOut">
               <a:rPr lang="en-US" smtClean="0"/>
               <a:pPr/>
-              <a:t>4/28/2026</a:t>
+              <a:t>5/2/2026</a:t>
             </a:fld>
             <a:endParaRPr lang="en-US" dirty="0"/>
           </a:p>
@@ -5382,7 +5382,7 @@
           <a:p>
             <a:fld id="{2CCFE9AC-F15C-4FA0-A6F1-298829FA691D}" type="datetimeFigureOut">
               <a:rPr lang="en-US"/>
-              <a:t>4/28/2026</a:t>
+              <a:t>5/2/2026</a:t>
             </a:fld>
             <a:endParaRPr/>
           </a:p>
@@ -5652,7 +5652,7 @@
           <a:p>
             <a:fld id="{2CCFE9AC-F15C-4FA0-A6F1-298829FA691D}" type="datetimeFigureOut">
               <a:rPr lang="en-US"/>
-              <a:t>4/28/2026</a:t>
+              <a:t>5/2/2026</a:t>
             </a:fld>
             <a:endParaRPr/>
           </a:p>
@@ -5844,7 +5844,7 @@
           <a:p>
             <a:fld id="{2CCFE9AC-F15C-4FA0-A6F1-298829FA691D}" type="datetimeFigureOut">
               <a:rPr lang="en-US"/>
-              <a:t>4/28/2026</a:t>
+              <a:t>5/2/2026</a:t>
             </a:fld>
             <a:endParaRPr/>
           </a:p>
@@ -6227,7 +6227,7 @@
             <a:fld id="{2CCFE9AC-F15C-4FA0-A6F1-298829FA691D}" type="datetimeFigureOut">
               <a:rPr lang="en-US" smtClean="0"/>
               <a:pPr/>
-              <a:t>4/28/2026</a:t>
+              <a:t>5/2/2026</a:t>
             </a:fld>
             <a:endParaRPr lang="en-US"/>
           </a:p>
@@ -6488,7 +6488,7 @@
           <a:p>
             <a:fld id="{2CCFE9AC-F15C-4FA0-A6F1-298829FA691D}" type="datetimeFigureOut">
               <a:rPr lang="en-US"/>
-              <a:t>4/28/2026</a:t>
+              <a:t>5/2/2026</a:t>
             </a:fld>
             <a:endParaRPr/>
           </a:p>
@@ -6862,7 +6862,7 @@
           <a:p>
             <a:fld id="{2CCFE9AC-F15C-4FA0-A6F1-298829FA691D}" type="datetimeFigureOut">
               <a:rPr lang="en-US"/>
-              <a:t>4/28/2026</a:t>
+              <a:t>5/2/2026</a:t>
             </a:fld>
             <a:endParaRPr/>
           </a:p>
@@ -6992,7 +6992,7 @@
           <a:p>
             <a:fld id="{2CCFE9AC-F15C-4FA0-A6F1-298829FA691D}" type="datetimeFigureOut">
               <a:rPr lang="en-US"/>
-              <a:t>4/28/2026</a:t>
+              <a:t>5/2/2026</a:t>
             </a:fld>
             <a:endParaRPr/>
           </a:p>
@@ -7099,7 +7099,7 @@
           <a:p>
             <a:fld id="{2CCFE9AC-F15C-4FA0-A6F1-298829FA691D}" type="datetimeFigureOut">
               <a:rPr lang="en-US"/>
-              <a:t>4/28/2026</a:t>
+              <a:t>5/2/2026</a:t>
             </a:fld>
             <a:endParaRPr/>
           </a:p>
@@ -7392,7 +7392,7 @@
           <a:p>
             <a:fld id="{2CCFE9AC-F15C-4FA0-A6F1-298829FA691D}" type="datetimeFigureOut">
               <a:rPr lang="en-US"/>
-              <a:t>4/28/2026</a:t>
+              <a:t>5/2/2026</a:t>
             </a:fld>
             <a:endParaRPr/>
           </a:p>
@@ -7662,7 +7662,7 @@
           <a:p>
             <a:fld id="{2CCFE9AC-F15C-4FA0-A6F1-298829FA691D}" type="datetimeFigureOut">
               <a:rPr lang="en-US"/>
-              <a:t>4/28/2026</a:t>
+              <a:t>5/2/2026</a:t>
             </a:fld>
             <a:endParaRPr/>
           </a:p>
@@ -7959,7 +7959,7 @@
             <a:fld id="{2CCFE9AC-F15C-4FA0-A6F1-298829FA691D}" type="datetimeFigureOut">
               <a:rPr lang="en-US" smtClean="0"/>
               <a:pPr/>
-              <a:t>4/28/2026</a:t>
+              <a:t>5/2/2026</a:t>
             </a:fld>
             <a:endParaRPr lang="en-US" dirty="0"/>
           </a:p>
@@ -8886,7 +8886,10 @@
           <a:bodyPr/>
           <a:lstStyle/>
           <a:p>
-            <a:endParaRPr lang="en-US"/>
+            <a:r>
+              <a:rPr lang="en-US"/>
+              <a:t>Batch Processing</a:t>
+            </a:r>
           </a:p>
         </p:txBody>
       </p:sp>
@@ -8905,6 +8908,36 @@
           <a:bodyPr/>
           <a:lstStyle/>
           <a:p>
+            <a:r>
+              <a:rPr lang="en-US"/>
+              <a:t>Xử lý theo lô dữ liệu</a:t>
+            </a:r>
+          </a:p>
+          <a:p>
+            <a:r>
+              <a:rPr lang="en-US"/>
+              <a:t>Định kì</a:t>
+            </a:r>
+          </a:p>
+          <a:p>
+            <a:r>
+              <a:rPr lang="en-US"/>
+              <a:t>Thời gian các lần xử lý dài</a:t>
+            </a:r>
+          </a:p>
+          <a:p>
+            <a:r>
+              <a:rPr lang="en-US"/>
+              <a:t>Sau khi lưu dữ liệu</a:t>
+            </a:r>
+          </a:p>
+          <a:p>
+            <a:r>
+              <a:rPr lang="en-US"/>
+              <a:t>Đặc trưng tĩnh</a:t>
+            </a:r>
+          </a:p>
+          <a:p>
             <a:endParaRPr lang="en-US"/>
           </a:p>
         </p:txBody>
@@ -8924,7 +8957,10 @@
           <a:bodyPr/>
           <a:lstStyle/>
           <a:p>
-            <a:endParaRPr lang="en-US"/>
+            <a:r>
+              <a:rPr lang="en-US"/>
+              <a:t>Streaming Processing</a:t>
+            </a:r>
           </a:p>
         </p:txBody>
       </p:sp>
@@ -8943,7 +8979,34 @@
           <a:bodyPr/>
           <a:lstStyle/>
           <a:p>
-            <a:endParaRPr lang="en-US"/>
+            <a:r>
+              <a:rPr lang="en-US"/>
+              <a:t>Lượng dữ liệu thay đổi</a:t>
+            </a:r>
+          </a:p>
+          <a:p>
+            <a:r>
+              <a:rPr lang="en-US"/>
+              <a:t>Ngay khi sinh dữ liệu</a:t>
+            </a:r>
+          </a:p>
+          <a:p>
+            <a:r>
+              <a:rPr lang="en-US"/>
+              <a:t>Độ trễ thấp</a:t>
+            </a:r>
+          </a:p>
+          <a:p>
+            <a:r>
+              <a:rPr lang="en-US"/>
+              <a:t>Lưu sau khi xử lý</a:t>
+            </a:r>
+          </a:p>
+          <a:p>
+            <a:r>
+              <a:rPr lang="en-US"/>
+              <a:t>Đặc trưng động</a:t>
+            </a:r>
           </a:p>
         </p:txBody>
       </p:sp>

</xml_diff>